<commit_message>
cp4d, datastage: sync from blueprint-ai, revalidated on CP4D 5.4.0 Patch 7
Copied verbatim from kastenhq/blueprint-ai PR #13 (branch cp4d-5.4-revalidation).

- cp4d: keeper image rebuilt (cpdctl v1.10.34, kubectl v1.34.9, tag 1.10.34-1),
  API key passed with --apikey-stdin, STORAGE_CLASS default ocs-storagecluster-ceph-rbd.
  The image reference is now ghcr.io/kastenhq/blueprint-ai/cp4d-backup (public,
  published by blueprint-ai CI) instead of docker.io/michaelcourcy/cp4d-backup.
  Also brings the concept deck and two README sections this copy was missing.
- datastage: IBM's 5.4.7 backup lock (new backupPosthook), PXRuntime label selector,
  5.4 validation record and upgrade notes.

Co-Authored-By: Claude Opus 5.5 <noreply@anthropic.com>
</commit_message>
<xml_diff>
--- a/cp4d/DESIGN.pptx
+++ b/cp4d/DESIGN.pptx
@@ -891,7 +891,7 @@
           <a:p/>
           <a:p>
             <a:r>
-              <a:t>The governing rule in [CLAUDE.md](../CLAUDE.md) is **"Kasten is the data mover — blueprints only</a:t>
+              <a:t>The governing rule in [AGENTS.md](../AGENTS.md) is **"Kasten is the data mover — blueprints only</a:t>
             </a:r>
           </a:p>
           <a:p>
@@ -1159,7 +1159,7 @@
           </a:p>
           <a:p>
             <a:r>
-              <a:t>| **Version skew** | Logical export/import is version-sensitive. V1 targets same-version DR (5.2 → 5.2); cross-version migration is a separate validation — see §7. |</a:t>
+              <a:t>| **Version skew** | Logical export/import is version-sensitive. V1 targets same-version DR (validated 5.2 → 5.2 and 5.4 → 5.4). One cross-version pair is measured — a 5.2.2 bundle imported into 5.4.0 — but no other pair; see §7. |</a:t>
             </a:r>
           </a:p>
           <a:p>
@@ -1816,7 +1816,7 @@
           </a:p>
           <a:p>
             <a:r>
-              <a:t>versioning (1.8.x) is **decoupled** from CP4D versioning (4.x / 5.x); the `cpdctl` README states:</a:t>
+              <a:t>versioning (1.x — 1.8.244 when this was written, 1.10.34 in the 5.4 re-validation) is **decoupled** from CP4D versioning (4.x / 5.x); the `cpdctl` README states:</a:t>
             </a:r>
           </a:p>
           <a:p/>
@@ -1859,12 +1859,38 @@
           </a:p>
           <a:p>
             <a:r>
-              <a:t>  against 5.2.x imports cleanly into 5.3.x — the bundle format is a property of the CP4D backend</a:t>
-            </a:r>
-          </a:p>
-          <a:p>
-            <a:r>
-              <a:t>  that produced it, not of the CLI. That is the **version-skew** risk listed in §4.</a:t>
+              <a:t>  against one release imports cleanly into another — the bundle format is a property of the CP4D</a:t>
+            </a:r>
+          </a:p>
+          <a:p>
+            <a:r>
+              <a:t>  backend that produced it, not of the CLI. That is the **version-skew** risk listed in §4.</a:t>
+            </a:r>
+          </a:p>
+          <a:p/>
+          <a:p>
+            <a:r>
+              <a:t>  **One pair is measured (2026-10-16):** after upgrading the cluster from 5.2.2 to 5.4.0 Patch 7,</a:t>
+            </a:r>
+          </a:p>
+          <a:p>
+            <a:r>
+              <a:t>  a project bundle exported by **5.2.2** (restored from a pre-upgrade Kasten restore point)</a:t>
+            </a:r>
+          </a:p>
+          <a:p>
+            <a:r>
+              <a:t>  imported into **5.4.0** with `restore.sh` and came back with its notebook, job and file data</a:t>
+            </a:r>
+          </a:p>
+          <a:p>
+            <a:r>
+              <a:t>  asset. That is the case that matters right after an upgrade, when every restore point still</a:t>
+            </a:r>
+          </a:p>
+          <a:p>
+            <a:r>
+              <a:t>  holds bundles from the old release. It says nothing about other pairs, or about a downgrade.</a:t>
             </a:r>
           </a:p>
         </p:txBody>
@@ -5106,7 +5132,7 @@
                 </a:solidFill>
                 <a:latin typeface="Calibri"/>
               </a:rPr>
-              <a:t>Validated end-to-end · Kasten 8.5.12 · OpenShift 4.18.6 · CP4D 5.2.x · cpdctl 1.8.244</a:t>
+              <a:t>Validated end-to-end · Kasten 9.0.7 · OpenShift 4.21.30 · CP4D 5.4.0 · cpdctl 1.10.34</a:t>
             </a:r>
           </a:p>
           <a:p>
@@ -10414,7 +10440,7 @@
                 </a:solidFill>
                 <a:latin typeface="Calibri"/>
               </a:rPr>
-              <a:t> — logical export/import is version-sensitive; V1 targets 5.2 → 5.2 (§7).</a:t>
+              <a:t> — logical export/import is version-sensitive; V1 targets same-version DR; 5.2.2 → 5.4.0 measured (§7).</a:t>
             </a:r>
           </a:p>
           <a:p>
@@ -13915,7 +13941,7 @@
                 </a:solidFill>
                 <a:latin typeface="Calibri"/>
               </a:rPr>
-              <a:t>, not one matched to your CP4D release — `cpdctl` versioning (1.8.x) is decoupled from CP4D versioning (4.x / 5.x).</a:t>
+              <a:t>, not one matched to your CP4D release — `cpdctl` versioning (1.x) is decoupled from CP4D versioning (4.x / 5.x).</a:t>
             </a:r>
           </a:p>
         </p:txBody>
@@ -14041,7 +14067,7 @@
                 </a:solidFill>
                 <a:latin typeface="Calibri"/>
               </a:rPr>
-              <a:t>1.8.244</a:t>
+              <a:t>1.10.34</a:t>
             </a:r>
           </a:p>
         </p:txBody>
@@ -14282,7 +14308,7 @@
                 </a:solidFill>
                 <a:latin typeface="Calibri"/>
               </a:rPr>
-              <a:t>CP4D 5.3.x</a:t>
+              <a:t>CP4D 5.4.x</a:t>
             </a:r>
           </a:p>
         </p:txBody>
@@ -14871,7 +14897,7 @@
                 <a:latin typeface="Calibri"/>
               </a:rPr>
               <a:t>bundle exported
-against CP4D 5.2.x</a:t>
+against CP4D 5.2.2</a:t>
             </a:r>
           </a:p>
         </p:txBody>
@@ -14973,7 +14999,7 @@
                 <a:latin typeface="Calibri"/>
               </a:rPr>
               <a:t>imported into
-CP4D 5.3.x</a:t>
+CP4D 5.4.0</a:t>
             </a:r>
           </a:p>
         </p:txBody>
@@ -15008,11 +15034,11 @@
             <a:r>
               <a:rPr sz="1300" b="1" i="0">
                 <a:solidFill>
-                  <a:srgbClr val="D03B3B"/>
-                </a:solidFill>
-                <a:latin typeface="Calibri"/>
-              </a:rPr>
-              <a:t>not promised</a:t>
+                  <a:srgbClr val="0CA30C"/>
+                </a:solidFill>
+                <a:latin typeface="Calibri"/>
+              </a:rPr>
+              <a:t>measured: works</a:t>
             </a:r>
           </a:p>
         </p:txBody>
@@ -15080,7 +15106,7 @@
             <a:avLst/>
           </a:prstGeom>
           <a:solidFill>
-            <a:srgbClr val="D03B3B"/>
+            <a:srgbClr val="FAB219"/>
           </a:solidFill>
           <a:ln>
             <a:noFill/>
@@ -15146,7 +15172,7 @@
                 </a:solidFill>
                 <a:latin typeface="Calibri"/>
               </a:rPr>
-              <a:t>The bundle format is a property of the </a:t>
+              <a:t>One pair measured after an upgrade. The bundle format is a property of the </a:t>
             </a:r>
             <a:r>
               <a:rPr sz="1200" b="1" i="0">
@@ -15164,7 +15190,7 @@
                 </a:solidFill>
                 <a:latin typeface="Calibri"/>
               </a:rPr>
-              <a:t>, not of the CLI.</a:t>
+              <a:t>, so every other pair still needs its own test.</a:t>
             </a:r>
           </a:p>
         </p:txBody>
@@ -15263,7 +15289,7 @@
                 </a:solidFill>
                 <a:latin typeface="Calibri"/>
               </a:rPr>
-              <a:t> “latest cpdctl handles all CP4D versions” means the CLI can *talk to* them. V1 targets same-version DR (5.2 → 5.2). Cross-version migration is a separate validation — it is the version-skew risk listed in §4.</a:t>
+              <a:t> “latest cpdctl handles all CP4D versions” means the CLI can *talk to* them. V1 targets same-version DR (validated 5.2 → 5.2 and 5.4 → 5.4). Any other version pair is a separate validation — it is the version-skew risk listed in §4.</a:t>
             </a:r>
           </a:p>
         </p:txBody>

</xml_diff>